<commit_message>
Translate project documentation and simplify README while preserving experiment evidence
</commit_message>
<xml_diff>
--- a/outputs/algorithm-design-v2/slides/Legal_AI_Algorithm_Design.pptx
+++ b/outputs/algorithm-design-v2/slides/Legal_AI_Algorithm_Design.pptx
@@ -449,7 +449,7 @@
           <a:lstStyle xmlns:a="http://schemas.openxmlformats.org/drawingml/2006/main"/>
           <a:p xmlns:a="http://schemas.openxmlformats.org/drawingml/2006/main">
             <a:r>
-              <a:t>今天我想讲清楚三个模块各自要设计算法解决什么。A把不同说法变成可复用的事实类别，但保留每个案件自己的身份与陈述状态。B找跨案件重复出现的关系组合。C根据有出处、经审阅的法律规则构造论证，并处理反驳。请指着下方直连线：C直接使用A的事实，B只帮助检索和比较，不能成为事实的唯一入口，更不能把常见模式升级成法律规则。当前材料是判决文书，首版是回顾性知识发现与论证重建，不把它说成判决前预测。完整项目还会经过因素、要件、请求和争点，本次聚焦这些层之间需要明确的算法。</a:t>
+              <a:t>A makes expressions reusable as fact categories while preserving case-specific identity and statement status. B discovers recurring relational combinations across cases. C builds arguments from sourced, reviewed rules and handles rebuttals. Point to the direct A-to-C line: B assists retrieval/comparison but is neither the only factual entry nor a source of legal rules. The present corpus is judgments, so version one supports retrospective discovery and argument reconstruction, not predecision prediction. The full project also includes factors, elements, requests and issues; these slides focus on algorithms connecting those layers.</a:t>
             </a:r>
           </a:p>
           <a:p xmlns:a="http://schemas.openxmlformats.org/drawingml/2006/main">
@@ -529,7 +529,7 @@
           <a:lstStyle xmlns:a="http://schemas.openxmlformats.org/drawingml/2006/main"/>
           <a:p xmlns:a="http://schemas.openxmlformats.org/drawingml/2006/main">
             <a:r>
-              <a:t>例子中两句话来自同一假想案件，涉及K1。它们可以共享PAID_FULL这个内容谓词，但“主张”和“法院认定”必须进入不同规范化陈述类，不能只保存在某个无人使用的metadata字段。付款family可以组织这些类别，但family关系不允许随意替换。每个实例保留当事人、合同、时间、原文范围和说话者。A的执行先抽取并逐槽核对来源，再用BM25和嵌入检索候选；判定器比较抽象签名的每个条件是否双向蕴含，两次交换顺序都通过才记EQ。任何缺失、分歧或新增行为都不能合并。下方“未交付”和“拒绝交付”说明词语相近不等价。这些来源和状态要求原PDF已经提出，我们的工作是落实执行与合并决策，不把要求本身说成创新。</a:t>
+              <a:t>The fictional K1 statements may share PAID_FULL as content, but allegation and court finding belong to different canonical statement classes. Status must affect computation rather than remain unused metadata. A payment family organizes classes without permitting substitution. Preserve parties, contract, time, source span and speaker for each instance. Extract/check slots, retrieve with BM25/embeddings, then test mutual entailment of each abstract-signature condition in both orders before EQ. Missing information, disagreement or added behavior blocks merging. Nondelivery and refusal to deliver illustrate similar wording without equivalence. The original PDF already requires provenance/status; implementation and merge decisions are the proposed work, not those requirements as novelty.</a:t>
             </a:r>
           </a:p>
           <a:p xmlns:a="http://schemas.openxmlformats.org/drawingml/2006/main">
@@ -609,7 +609,7 @@
           <a:lstStyle xmlns:a="http://schemas.openxmlformats.org/drawingml/2006/main"/>
           <a:p xmlns:a="http://schemas.openxmlformats.org/drawingml/2006/main">
             <a:r>
-              <a:t>图中每个节点代表一个同状态、同语境的抽象语义签名，每条线代表已经核验的EQ。没画出的边可能未核验，也可能不等价，数据库会区分；两者都不能用于同簇。假设贪心先选ab，就只能留下c和d两个单例。联合选择ac与bd保留两个已核验关系，同时没有串联未经核验的边。具体实现用二元zij表示同簇，所有非EQ边固定0，三元传递约束保证划分，最大化簇内EQ边数。分量80个节点以内限时60秒，大分量回退完整准入贪心。新证据或误判修复后重算变化前后连通分量，版本化发布。这是条件图目标优势，绝不等于语言判断更正确。最直接对照是完全相同EQ图上的贪心；另与原PDF完整代表核验、EDC同schema、Cequel和LSCK比较。若额外求解没有增加真实正确复用，就保留贪心。珊瑚色标记本页的选择结果，不表示已经证明的新贡献。</a:t>
+              <a:t>Nodes are abstract signatures with shared status/context; edges are checked EQ judgments. Missing edges are either unchecked or non-equivalent, distinguished in storage but both unavailable for co-clustering. Greedy ab leaves c and d singleton; joint ac/bd retains two checked relations without chaining unchecked edges. Binary zij represents same-cluster membership; non-EQ pairs are zero and triangle constraints enforce a partition. Maximize within-cluster EQ edges. Components up to 80 nodes receive 60 seconds; larger ones use full-admission greedy fallback. Recompute affected old/new components after evidence changes and version the result. This is a conditional graph-objective advantage, not improved language judgment. Compare greedy on the same EQ graph and the complete PDF representative-checking pipeline, EDC with shared schema, Cequel and LSCK. Retain greedy if extra solving does not improve correct reuse. Coral marks the example selection, not an established contribution.</a:t>
             </a:r>
           </a:p>
           <a:p xmlns:a="http://schemas.openxmlformats.org/drawingml/2006/main">
@@ -689,7 +689,7 @@
           <a:lstStyle xmlns:a="http://schemas.openxmlformats.org/drawingml/2006/main"/>
           <a:p xmlns:a="http://schemas.openxmlformats.org/drawingml/2006/main">
             <a:r>
-              <a:t>继续K1/K2例子。最初只有K1已付款、K2未交付，两者在同一案件出现，却不是同一合同上的组合。查询重复使用同一个K变量，精确连接失败。后来有K1未交付的法院认定，才得到完整见证。主张视图与法院认定视图分别计算。算法从单原子开始，每次增加共享实体或事件变量的一个原子；规范变量命名与原子顺序，消除重复，再执行带类型的关系连接。首版限制2到4个内容原子、最多6个变量。每个case/claim/stage有一个见证就记一次支持，诉讼组另计独立重复，分母固定。增加合取条件只会缩小见证集合，可安全剪枝已知不频繁的合法前缀。未知计数和超时不能当0。gSpan已经能保留关系，所以公平对照必须给它相同typed graph与身份状态，比较搜索成本和覆盖，而不能声称只有本方案懂关系。</a:t>
+              <a:t>Initially K1 is paid and K2 undelivered. Co-occurrence in one case is not a same-contract witness; repeating K in the query makes the join fail. A later K1 nondelivery finding supplies a witness. Allegation and court-found views run separately. Begin with one atom and extend by one sharing an entity/event variable. Canonicalize variables/atom order and execute typed joins. Initially use 2–4 content atoms and at most six variables. Count one support per case/request/stage, with dispute groups separately tracking independent recurrence and a fixed denominator. Added conjunctions only shrink witness sets, supporting pruning of valid known-infrequent prefixes. Unknown counts/timeouts are not zero. gSpan already preserves structure, so give it the same typed graph, identities and states and compare cost/coverage rather than claiming exclusive relational ability.</a:t>
             </a:r>
           </a:p>
           <a:p xmlns:a="http://schemas.openxmlformats.org/drawingml/2006/main">
@@ -769,7 +769,7 @@
           <a:lstStyle xmlns:a="http://schemas.openxmlformats.org/drawingml/2006/main"/>
           <a:p xmlns:a="http://schemas.openxmlformats.org/drawingml/2006/main">
             <a:r>
-              <a:t>生成候选还不够，一批高度重复模式会浪费阅读时间。首选把模式写成字典条目，每次用模式必须同时写出b、s、K绑定；无法覆盖的事实原样保存。整数规划同时决定选哪些条目、使用哪些见证、保留哪些literal，最小化定义加使用加剩余事实的总位数。所有字段和ID宽度固定，重叠宏仍支付完整成本，每个原子必须可重建。候选首先要求至少5个诉讼组存在见证；选中的模式至少在3组实际使用，这是不同阶段的两个约束。首版每模式每单元最多用一次以控制长案件主导，解除上限作为消融。300秒到限保留最好可行解并报告gap。达到最优时只保证同候选、同编码下不比贪心的位数差，不能保证更有法律价值。KG-MDL是最接近的强对照，SLIM/Snor、最大覆盖和同编码贪心也要比较。若只是省几bit却降低专家有效产出，就换目标或采用贪心。表中三条是使用示例，不是数据支持量，也不是实测数字。</a:t>
+              <a:t>Redundant patterns waste reading effort. Dictionary calls retain b, s and K bindings; uncovered facts remain literal. Integer programming jointly chooses entries, witness calls and literals to minimize definition, invocation and residual bits. Fix field/ID widths, charge overlapping macros fully and reconstruct every atom. Discovery requires witnesses in at least five dispute groups; selected entries require actual use in at least three groups. These are different constraints at different stages. Version one permits one call per pattern/unit to limit long-case dominance; removing that cap is an ablation. At 300 seconds retain the best feasible solution and report the gap. Optimality guarantees no worse bits than greedy only for the same candidates/code, not legal value. Compare KG-MDL, SLIM/Snor, maximum coverage and same-code greedy. Change the objective or use greedy if small savings reduce expert utility. The three displayed calls are illustrations, not measured support or code lengths.</a:t>
             </a:r>
           </a:p>
           <a:p xmlns:a="http://schemas.openxmlformats.org/drawingml/2006/main">
@@ -849,7 +849,7 @@
           <a:lstStyle xmlns:a="http://schemas.openxmlformats.org/drawingml/2006/main"/>
           <a:p xmlns:a="http://schemas.openxmlformats.org/drawingml/2006/main">
             <a:r>
-              <a:t>上方是实现流程：从法源提取条件、例外和范围，专家审阅后编译到共享谓词，构造带原文及规则ID的论证。来源记录本身只说明文书写了什么，对象事实由可废止投射产生，所以两份相反记录可以共存并相互反驳。下方把同一K1的延期冲突画开：A支持未延期，B支持已延期，二者的事实投射互相rebut。R使用A以及其他已满足前提推出要件；r2利用延期攻击r1的这次适用。红色路径压缩了r2的中间节点，完整实现保留它。假设相关规则无优先关系，grounded从空集迭代，未解决冲突使R仍未决。它不是多数投票，也不靠模型选更可信的一边。规则优先仅采用审阅过的偏序，具体last-link elitist比较写在文档。undercut不被结论优先级挡住，rebut只直接针对可废止子论证。规则包限制有限、无函数、正向依赖DAG，攻击图可以有环。完整图构造超限时不发布认证结论。</a:t>
+              <a:t>Extract conditions, exceptions and scope from law, obtain expert review, compile to shared predicates and build arguments with source/rule IDs. A source record states what the document says; defeasible projections produce object-level facts so contrary records coexist and rebut. In the K1 example, A supports no extension and B supports extension; projections mutually rebut. R combines A with other premises, while r2 uses extension to attack that application of r1. The red path abbreviates r2 visually; implementation retains its node. With equal priority, grounded iteration from empty leaves R unresolved. This is neither voting nor model credibility selection. Use reviewed partial priorities and the documented last-link elitist comparison. Undercuts are not blocked by conclusion priority; rebuts directly target defeasible subarguments. The package is finite, function-free and has a positive-dependency DAG, though attacks can cycle. Construction limits prevent certified conclusions from incomplete graphs.</a:t>
             </a:r>
           </a:p>
           <a:p xmlns:a="http://schemas.openxmlformats.org/drawingml/2006/main">
@@ -929,7 +929,7 @@
           <a:lstStyle xmlns:a="http://schemas.openxmlformats.org/drawingml/2006/main"/>
           <a:p xmlns:a="http://schemas.openxmlformats.org/drawingml/2006/main">
             <a:r>
-              <a:t>贯穿例子的原始记录缺少K1到期日期，所以即使B已经发现已付款加未交付，也不能补出法律前提。然后区分两种经审阅规则。若法律条件本来要求明确排除延期，缺少这项依据就无法构造论证。若法律安排允许满足基本条件后默认适用，延期作为抗辩或例外攻击，那么没有延期记录时可以构造可废止论证，但绝不生成“没有延期”的事实。这种规则模式必须事先根据法源确定，不能为了当前案件得到结论而临时改变。未审阅模式的规则不运行。双方延期论证相互冲突则按上一页保留未决。完整轨迹展示来源、投射、规则版本、攻击、状态及缺失项。C的价值假设是减少漏条件和随意裁决，不是保证法律正确；成熟ASPIC+引擎若支持同语义应直接复用，结构清单在简单争点同样好时也应保留。</a:t>
+              <a:t>The running example lacks K1's due date; payment plus nondelivery cannot fill that legal premise. Distinguish reviewed rule policies. If explicit exclusion of extension is required, missing evidence prevents an argument. If ordinary conditions permit default application and extension attacks it, an argument can exist without an extension record, without inventing a no-extension fact. Source-based policy must be fixed before the case, not chosen to obtain a conclusion. Unreviewed policies do not execute. Conflicting extension arguments remain unresolved as on the previous slide. Traces include sources, projections, rule version, attacks, status and gaps. The hypothesis is fewer omitted conditions/arbitrary decisions, not guaranteed legal truth. Reuse a mature ASPIC+ engine supporting the same semantics; retain a simple checklist when equally effective.</a:t>
             </a:r>
           </a:p>
           <a:p xmlns:a="http://schemas.openxmlformats.org/drawingml/2006/main">
@@ -1009,7 +1009,7 @@
           <a:lstStyle xmlns:a="http://schemas.openxmlformats.org/drawingml/2006/main"/>
           <a:p xmlns:a="http://schemas.openxmlformats.org/drawingml/2006/main">
             <a:r>
-              <a:t>我的提议不是三个全新算法，而是把现成方法组合成可以实现、可以被推翻的选择。A的条件优势来自严格准入和联合处理合法合并竞争，但多花的核验预算必须计入。B的优势假设来自保留绑定、明确搜索语言和压缩冗余，gSpan和KG-MDL得到相同信息后可能同样好。C的形式语义已经成熟，核心工程难点是把来源、规则、例外与优先编译正确，不必重新发明论证引擎。先针对一个法律争点做原型。开发、发现、确认按关联诉讼组隔离，事实和规则人工核验输入实验与自动输入实验分开。评价必须同时看覆盖、正确产出和成本，全singleton与全拒答不能靠零错误获胜。当前已核验本地数据有6954条记录但领域混合、没有现成金标准；运行的小型机制检查只验证抽象图和合成例子，不是实际案件成绩。会议要确定的是真正要保留的法律差异、第一争点和专家审查安排。</a:t>
+              <a:t>These are implementable, falsifiable choices combining established algorithms. A's conditional advantage is strict admission plus joint legal-merge competition, with all additional checking costs counted. B's hypothesis concerns binding, explicit language and redundancy reduction; equally informed gSpan/KG-MDL may match it. C uses mature formal semantics; the challenge is faithful compilation of sources, rules, exceptions and priorities. Start with one issue. Separate development/discovery/confirmation by related dispute groups and separate reviewed-input from automatic-input experiments. Evaluate coverage, correct output and cost together; singleton-only or reject-all cannot win through zero errors. The local inventory contains 6,954 mixed-domain records without ready gold. Small mechanism checks validate abstract/synthetic examples, not real-case performance. The meeting should settle protected legal distinctions, the first issue and expert-review arrangements.</a:t>
             </a:r>
           </a:p>
           <a:p xmlns:a="http://schemas.openxmlformats.org/drawingml/2006/main">

</xml_diff>